<commit_message>
Slide del pitch con indirizzi veri, scaletta della presentazione, roadmap
Co-Authored-By: Claude Fable 5.1 <noreply@anthropic.com>
</commit_message>
<xml_diff>
--- a/pitch/DWC-pitch.pptx
+++ b/pitch/DWC-pitch.pptx
@@ -5823,7 +5823,7 @@
                 <a:ea typeface="Calibri" pitchFamily="34" charset="-122"/>
                 <a:cs typeface="Calibri" pitchFamily="34" charset="-120"/>
               </a:rPr>
-              <a:t>Buoni Edenred oltre il tetto</a:t>
+              <a:t>Il cappello, dal vivo</a:t>
             </a:r>
             <a:endParaRPr lang="en-US" sz="1400" dirty="0"/>
           </a:p>
@@ -5862,7 +5862,7 @@
                 <a:ea typeface="Calibri" pitchFamily="34" charset="-122"/>
                 <a:cs typeface="Calibri" pitchFamily="34" charset="-120"/>
               </a:rPr>
-              <a:t>Rifiutati dal contratto, spiegati dall'AI</a:t>
+              <a:t>Una collega lo chiede all'assistente dal suo telefono, conferma e firma</a:t>
             </a:r>
             <a:endParaRPr lang="en-US" sz="1150" dirty="0"/>
           </a:p>
@@ -5967,7 +5967,7 @@
                 <a:ea typeface="Calibri" pitchFamily="34" charset="-122"/>
                 <a:cs typeface="Calibri" pitchFamily="34" charset="-120"/>
               </a:rPr>
-              <a:t>Weekend su preventivo</a:t>
+              <a:t>Consegna confermata</a:t>
             </a:r>
             <a:endParaRPr lang="en-US" sz="1400" dirty="0"/>
           </a:p>
@@ -6006,7 +6006,7 @@
                 <a:ea typeface="Calibri" pitchFamily="34" charset="-122"/>
                 <a:cs typeface="Calibri" pitchFamily="34" charset="-120"/>
               </a:rPr>
-              <a:t>Richiesta → prezzo → accettazione → erogazione, con DWC bruciati</a:t>
+              <a:t>Il banco conferma: i DWC in custodia vengono bruciati</a:t>
             </a:r>
             <a:endParaRPr lang="en-US" sz="1150" dirty="0"/>
           </a:p>
@@ -6111,7 +6111,7 @@
                 <a:ea typeface="Calibri" pitchFamily="34" charset="-122"/>
                 <a:cs typeface="Calibri" pitchFamily="34" charset="-120"/>
               </a:rPr>
-              <a:t>Scambio tra colleghi</a:t>
+              <a:t>Oltre il tetto</a:t>
             </a:r>
             <a:endParaRPr lang="en-US" sz="1400" dirty="0"/>
           </a:p>
@@ -6150,7 +6150,7 @@
                 <a:ea typeface="Calibri" pitchFamily="34" charset="-122"/>
                 <a:cs typeface="Calibri" pitchFamily="34" charset="-120"/>
               </a:rPr>
-              <a:t>E il tentativo verso un estraneo: bloccato dal contratto</a:t>
+              <a:t>80 € di buoni pasto: il contratto rifiuterebbe, l'AI spiega e propone 50</a:t>
             </a:r>
             <a:endParaRPr lang="en-US" sz="1150" dirty="0"/>
           </a:p>
@@ -7615,11 +7615,11 @@
           <a:solidFill>
             <a:srgbClr val="FFFFFF"/>
           </a:solidFill>
-          <a:ln w="25400">
+          <a:ln w="9525">
             <a:solidFill>
-              <a:srgbClr val="E84142"/>
+              <a:srgbClr val="E2DED3"/>
             </a:solidFill>
-            <a:prstDash val="dash"/>
+            <a:prstDash val="solid"/>
           </a:ln>
         </p:spPr>
       </p:sp>
@@ -7670,34 +7670,34 @@
         </p:nvSpPr>
         <p:spPr>
           <a:xfrm>
-            <a:off x="4800600" y="2011680"/>
-            <a:ext cx="3566160" cy="685800"/>
-          </a:xfrm>
-          <a:prstGeom prst="rect">
-            <a:avLst/>
-          </a:prstGeom>
-          <a:noFill/>
-          <a:ln/>
-        </p:spPr>
-        <p:txBody>
-          <a:bodyPr wrap="square" lIns="0" tIns="0" rIns="0" bIns="0" rtlCol="0" anchor="ctr"/>
-          <a:lstStyle/>
-          <a:p>
-            <a:pPr indent="0" marL="0">
-              <a:buNone/>
-            </a:pPr>
-            <a:r>
-              <a:rPr lang="en-US" sz="1700" b="1" dirty="0">
-                <a:solidFill>
-                  <a:srgbClr val="E84142"/>
-                </a:solidFill>
-                <a:latin typeface="Calibri" pitchFamily="34" charset="0"/>
-                <a:ea typeface="Calibri" pitchFamily="34" charset="-122"/>
-                <a:cs typeface="Calibri" pitchFamily="34" charset="-120"/>
-              </a:rPr>
-              <a:t>INDIRIZZI DA INSERIRE DOPO LA PUBBLICAZIONE</a:t>
-            </a:r>
-            <a:endParaRPr lang="en-US" sz="1700" dirty="0"/>
+            <a:off x="4800600" y="2103120"/>
+            <a:ext cx="3566160" cy="237744"/>
+          </a:xfrm>
+          <a:prstGeom prst="rect">
+            <a:avLst/>
+          </a:prstGeom>
+          <a:noFill/>
+          <a:ln/>
+        </p:spPr>
+        <p:txBody>
+          <a:bodyPr wrap="square" lIns="0" tIns="0" rIns="0" bIns="0" rtlCol="0" anchor="t"/>
+          <a:lstStyle/>
+          <a:p>
+            <a:pPr indent="0" marL="0">
+              <a:buNone/>
+            </a:pPr>
+            <a:r>
+              <a:rPr lang="en-US" sz="1300" b="1" dirty="0">
+                <a:solidFill>
+                  <a:srgbClr val="1C1B19"/>
+                </a:solidFill>
+                <a:latin typeface="Calibri" pitchFamily="34" charset="0"/>
+                <a:ea typeface="Calibri" pitchFamily="34" charset="-122"/>
+                <a:cs typeface="Calibri" pitchFamily="34" charset="-120"/>
+              </a:rPr>
+              <a:t>DWCToken</a:t>
+            </a:r>
+            <a:endParaRPr lang="en-US" sz="1300" dirty="0"/>
           </a:p>
         </p:txBody>
       </p:sp>
@@ -7709,8 +7709,8 @@
         </p:nvSpPr>
         <p:spPr>
           <a:xfrm>
-            <a:off x="4800600" y="2834640"/>
-            <a:ext cx="3566160" cy="237744"/>
+            <a:off x="4800600" y="2359152"/>
+            <a:ext cx="3611880" cy="237744"/>
           </a:xfrm>
           <a:prstGeom prst="rect">
             <a:avLst/>
@@ -7726,56 +7726,56 @@
               <a:buNone/>
             </a:pPr>
             <a:r>
-              <a:rPr lang="en-US" sz="1300" b="1" dirty="0">
-                <a:solidFill>
-                  <a:srgbClr val="1C1B19"/>
-                </a:solidFill>
-                <a:latin typeface="Calibri" pitchFamily="34" charset="0"/>
-                <a:ea typeface="Calibri" pitchFamily="34" charset="-122"/>
-                <a:cs typeface="Calibri" pitchFamily="34" charset="-120"/>
-              </a:rPr>
-              <a:t>DWCToken</a:t>
-            </a:r>
-            <a:endParaRPr lang="en-US" sz="1300" dirty="0"/>
-          </a:p>
-        </p:txBody>
-      </p:sp>
-      <p:sp>
-        <p:nvSpPr>
-          <p:cNvPr id="20" name="Text 15"/>
-          <p:cNvSpPr txBox="1"/>
-          <p:nvPr/>
-        </p:nvSpPr>
-        <p:spPr>
-          <a:xfrm>
-            <a:off x="6949440" y="2834640"/>
-            <a:ext cx="1417320" cy="237744"/>
-          </a:xfrm>
-          <a:prstGeom prst="rect">
-            <a:avLst/>
-          </a:prstGeom>
-          <a:noFill/>
-          <a:ln/>
-        </p:spPr>
-        <p:txBody>
-          <a:bodyPr wrap="square" lIns="0" tIns="0" rIns="0" bIns="0" rtlCol="0" anchor="t"/>
-          <a:lstStyle/>
-          <a:p>
-            <a:pPr algn="r" indent="0" marL="0">
-              <a:buNone/>
-            </a:pPr>
-            <a:r>
-              <a:rPr lang="en-US" sz="1200" dirty="0">
-                <a:solidFill>
-                  <a:srgbClr val="E84142"/>
+              <a:rPr lang="en-US" sz="1050" dirty="0">
+                <a:solidFill>
+                  <a:srgbClr val="6B6862"/>
                 </a:solidFill>
                 <a:latin typeface="Consolas" pitchFamily="34" charset="0"/>
                 <a:ea typeface="Consolas" pitchFamily="34" charset="-122"/>
                 <a:cs typeface="Consolas" pitchFamily="34" charset="-120"/>
               </a:rPr>
-              <a:t>0x…</a:t>
-            </a:r>
-            <a:endParaRPr lang="en-US" sz="1200" dirty="0"/>
+              <a:t>0xD27985aAC8FB91c0d6a73d329bDCe0707Df0A81C</a:t>
+            </a:r>
+            <a:endParaRPr lang="en-US" sz="1050" dirty="0"/>
+          </a:p>
+        </p:txBody>
+      </p:sp>
+      <p:sp>
+        <p:nvSpPr>
+          <p:cNvPr id="20" name="Text 15"/>
+          <p:cNvSpPr txBox="1"/>
+          <p:nvPr/>
+        </p:nvSpPr>
+        <p:spPr>
+          <a:xfrm>
+            <a:off x="4800600" y="2834640"/>
+            <a:ext cx="3566160" cy="237744"/>
+          </a:xfrm>
+          <a:prstGeom prst="rect">
+            <a:avLst/>
+          </a:prstGeom>
+          <a:noFill/>
+          <a:ln/>
+        </p:spPr>
+        <p:txBody>
+          <a:bodyPr wrap="square" lIns="0" tIns="0" rIns="0" bIns="0" rtlCol="0" anchor="t"/>
+          <a:lstStyle/>
+          <a:p>
+            <a:pPr indent="0" marL="0">
+              <a:buNone/>
+            </a:pPr>
+            <a:r>
+              <a:rPr lang="en-US" sz="1300" b="1" dirty="0">
+                <a:solidFill>
+                  <a:srgbClr val="1C1B19"/>
+                </a:solidFill>
+                <a:latin typeface="Calibri" pitchFamily="34" charset="0"/>
+                <a:ea typeface="Calibri" pitchFamily="34" charset="-122"/>
+                <a:cs typeface="Calibri" pitchFamily="34" charset="-120"/>
+              </a:rPr>
+              <a:t>WelfareRules</a:t>
+            </a:r>
+            <a:endParaRPr lang="en-US" sz="1300" dirty="0"/>
           </a:p>
         </p:txBody>
       </p:sp>
@@ -7787,8 +7787,8 @@
         </p:nvSpPr>
         <p:spPr>
           <a:xfrm>
-            <a:off x="4800600" y="3310128"/>
-            <a:ext cx="3566160" cy="237744"/>
+            <a:off x="4800600" y="3090672"/>
+            <a:ext cx="3611880" cy="237744"/>
           </a:xfrm>
           <a:prstGeom prst="rect">
             <a:avLst/>
@@ -7804,56 +7804,56 @@
               <a:buNone/>
             </a:pPr>
             <a:r>
-              <a:rPr lang="en-US" sz="1300" b="1" dirty="0">
-                <a:solidFill>
-                  <a:srgbClr val="1C1B19"/>
-                </a:solidFill>
-                <a:latin typeface="Calibri" pitchFamily="34" charset="0"/>
-                <a:ea typeface="Calibri" pitchFamily="34" charset="-122"/>
-                <a:cs typeface="Calibri" pitchFamily="34" charset="-120"/>
-              </a:rPr>
-              <a:t>WelfareRules</a:t>
-            </a:r>
-            <a:endParaRPr lang="en-US" sz="1300" dirty="0"/>
-          </a:p>
-        </p:txBody>
-      </p:sp>
-      <p:sp>
-        <p:nvSpPr>
-          <p:cNvPr id="22" name="Text 17"/>
-          <p:cNvSpPr txBox="1"/>
-          <p:nvPr/>
-        </p:nvSpPr>
-        <p:spPr>
-          <a:xfrm>
-            <a:off x="6949440" y="3310128"/>
-            <a:ext cx="1417320" cy="237744"/>
-          </a:xfrm>
-          <a:prstGeom prst="rect">
-            <a:avLst/>
-          </a:prstGeom>
-          <a:noFill/>
-          <a:ln/>
-        </p:spPr>
-        <p:txBody>
-          <a:bodyPr wrap="square" lIns="0" tIns="0" rIns="0" bIns="0" rtlCol="0" anchor="t"/>
-          <a:lstStyle/>
-          <a:p>
-            <a:pPr algn="r" indent="0" marL="0">
-              <a:buNone/>
-            </a:pPr>
-            <a:r>
-              <a:rPr lang="en-US" sz="1200" dirty="0">
-                <a:solidFill>
-                  <a:srgbClr val="E84142"/>
+              <a:rPr lang="en-US" sz="1050" dirty="0">
+                <a:solidFill>
+                  <a:srgbClr val="6B6862"/>
                 </a:solidFill>
                 <a:latin typeface="Consolas" pitchFamily="34" charset="0"/>
                 <a:ea typeface="Consolas" pitchFamily="34" charset="-122"/>
                 <a:cs typeface="Consolas" pitchFamily="34" charset="-120"/>
               </a:rPr>
-              <a:t>0x…</a:t>
-            </a:r>
-            <a:endParaRPr lang="en-US" sz="1200" dirty="0"/>
+              <a:t>0x25b80Ef7C77FD7C9812Da69DD4271612b5fb642a</a:t>
+            </a:r>
+            <a:endParaRPr lang="en-US" sz="1050" dirty="0"/>
+          </a:p>
+        </p:txBody>
+      </p:sp>
+      <p:sp>
+        <p:nvSpPr>
+          <p:cNvPr id="22" name="Text 17"/>
+          <p:cNvSpPr txBox="1"/>
+          <p:nvPr/>
+        </p:nvSpPr>
+        <p:spPr>
+          <a:xfrm>
+            <a:off x="4800600" y="3566160"/>
+            <a:ext cx="3566160" cy="237744"/>
+          </a:xfrm>
+          <a:prstGeom prst="rect">
+            <a:avLst/>
+          </a:prstGeom>
+          <a:noFill/>
+          <a:ln/>
+        </p:spPr>
+        <p:txBody>
+          <a:bodyPr wrap="square" lIns="0" tIns="0" rIns="0" bIns="0" rtlCol="0" anchor="t"/>
+          <a:lstStyle/>
+          <a:p>
+            <a:pPr indent="0" marL="0">
+              <a:buNone/>
+            </a:pPr>
+            <a:r>
+              <a:rPr lang="en-US" sz="1300" b="1" dirty="0">
+                <a:solidFill>
+                  <a:srgbClr val="1C1B19"/>
+                </a:solidFill>
+                <a:latin typeface="Calibri" pitchFamily="34" charset="0"/>
+                <a:ea typeface="Calibri" pitchFamily="34" charset="-122"/>
+                <a:cs typeface="Calibri" pitchFamily="34" charset="-120"/>
+              </a:rPr>
+              <a:t>WelfareMarketplace</a:t>
+            </a:r>
+            <a:endParaRPr lang="en-US" sz="1300" dirty="0"/>
           </a:p>
         </p:txBody>
       </p:sp>
@@ -7865,8 +7865,8 @@
         </p:nvSpPr>
         <p:spPr>
           <a:xfrm>
-            <a:off x="4800600" y="3785616"/>
-            <a:ext cx="3566160" cy="237744"/>
+            <a:off x="4800600" y="3822192"/>
+            <a:ext cx="3611880" cy="237744"/>
           </a:xfrm>
           <a:prstGeom prst="rect">
             <a:avLst/>
@@ -7882,56 +7882,17 @@
               <a:buNone/>
             </a:pPr>
             <a:r>
-              <a:rPr lang="en-US" sz="1300" b="1" dirty="0">
-                <a:solidFill>
-                  <a:srgbClr val="1C1B19"/>
-                </a:solidFill>
-                <a:latin typeface="Calibri" pitchFamily="34" charset="0"/>
-                <a:ea typeface="Calibri" pitchFamily="34" charset="-122"/>
-                <a:cs typeface="Calibri" pitchFamily="34" charset="-120"/>
-              </a:rPr>
-              <a:t>WelfareMarketplace</a:t>
-            </a:r>
-            <a:endParaRPr lang="en-US" sz="1300" dirty="0"/>
-          </a:p>
-        </p:txBody>
-      </p:sp>
-      <p:sp>
-        <p:nvSpPr>
-          <p:cNvPr id="24" name="Text 19"/>
-          <p:cNvSpPr txBox="1"/>
-          <p:nvPr/>
-        </p:nvSpPr>
-        <p:spPr>
-          <a:xfrm>
-            <a:off x="6949440" y="3785616"/>
-            <a:ext cx="1417320" cy="237744"/>
-          </a:xfrm>
-          <a:prstGeom prst="rect">
-            <a:avLst/>
-          </a:prstGeom>
-          <a:noFill/>
-          <a:ln/>
-        </p:spPr>
-        <p:txBody>
-          <a:bodyPr wrap="square" lIns="0" tIns="0" rIns="0" bIns="0" rtlCol="0" anchor="t"/>
-          <a:lstStyle/>
-          <a:p>
-            <a:pPr algn="r" indent="0" marL="0">
-              <a:buNone/>
-            </a:pPr>
-            <a:r>
-              <a:rPr lang="en-US" sz="1200" dirty="0">
-                <a:solidFill>
-                  <a:srgbClr val="E84142"/>
+              <a:rPr lang="en-US" sz="1050" dirty="0">
+                <a:solidFill>
+                  <a:srgbClr val="6B6862"/>
                 </a:solidFill>
                 <a:latin typeface="Consolas" pitchFamily="34" charset="0"/>
                 <a:ea typeface="Consolas" pitchFamily="34" charset="-122"/>
                 <a:cs typeface="Consolas" pitchFamily="34" charset="-120"/>
               </a:rPr>
-              <a:t>0x…</a:t>
-            </a:r>
-            <a:endParaRPr lang="en-US" sz="1200" dirty="0"/>
+              <a:t>0x6D7F0f1dB66B299057542ee89E1ddB22E24746d9</a:t>
+            </a:r>
+            <a:endParaRPr lang="en-US" sz="1050" dirty="0"/>
           </a:p>
         </p:txBody>
       </p:sp>

</xml_diff>